<commit_message>
docs(smart-align-agent): ⑥ Pain 재정의 + 1차 PoC 선정 논리 명문화
⑥을 "시험측정 후 오인식 수정"(1회성)에서 "Recipe Setup 후 공정
variation으로 실측 이미지가 등록 template과 달라져(이미지 차이)
오측·인식 실패가 반복 발생 → 반복 수정 = Recipe Management 최대 병목"
으로 재정의. Discovery→Design 추적성 체인(02·03·04·05·06·07·08) +
요약 내러티브(03·04 적용)·발표요약·README에 일관 반영.

1차 PoC를 Align fail 대응으로 좁힌 근거 추가: align fail 수정 ≈ ⑥
오측/인식 실패 수정(같은 개념) + align image 재등록(recipe tuning)이
비교적 간단 → 최대 병목 정조준 + tractable 진입점.

발표요약.pptx(14장)·세트.pptx(79장) 재생성. ASCII 박스 정렬(76/72) 보존.
SPEC.md: painpoint 표 헤더 inline-code 표기 통일(경미).

Co-Authored-By: Claude Opus 4.8 (1M context) <noreply@anthropic.com>
Claude-Session: https://claude.ai/code/session_01JWkzLeVT7YBBxfVMYeFWnw
</commit_message>
<xml_diff>
--- a/my-task/AIX_POC/프로젝트_smart_align_agent/07-적용_CDSEM_실행기획_발표요약.pptx
+++ b/my-task/AIX_POC/프로젝트_smart_align_agent/07-적용_CDSEM_실행기획_발표요약.pptx
@@ -1005,7 +1005,7 @@
           <a:lstStyle/>
           <a:p>
             <a:r>
-              <a:t>"첫 단계는 추적성입니다. 이 과제는 '리드타임 단축'이라는 조직 목표에서 연역됐고, 단순 효율화가 아니라 사람 작업시간 제약을 풀어 처리량 상한 자체를 올립니다."</a:t>
+              <a:t>"첫 단계는 추적성입니다. 이 과제는 'R&amp;D 디바이스 개발 지연 최소화'라는 조직 목표에서 연역됐고, 일관 기준(Skew Zero)과 24h 무중단(가동률↑)으로 장비 운영/관리·검계측을 최적화합니다."</a:t>
             </a:r>
           </a:p>
         </p:txBody>
@@ -1075,7 +1075,7 @@
           <a:lstStyle/>
           <a:p>
             <a:r>
-              <a:t>"AI를 모든 업무에 넣지 않습니다. 4개 영역 중 반복성·공수가 최대이고 데이터가 이미 있는 Recipe Creation을 1차로, 야간/주말 공백이 큰 안정성 모니터링을 차기로 정했습니다."</a:t>
+              <a:t>"AI를 모든 업무에 넣지 않습니다. 4개 영역 중 반복성·공수가 최대이고 데이터가 이미 있는 Recipe Creation을 1차로, 야간/주말 공백이 큰 Recipe 준수 모니터링을 차기로 정했습니다. 장비 운영/관리와 장비 개발·양산 이관은 물리 작업·외부 협력이라 범위 밖입니다."</a:t>
             </a:r>
           </a:p>
         </p:txBody>
@@ -4572,7 +4572,7 @@
                 </a:solidFill>
                 <a:latin typeface="맑은 고딕"/>
               </a:rPr>
-              <a:t>CD-SEM Recipe Creation 자동화</a:t>
+              <a:t>CD-SEM Auto Recipe Creation</a:t>
             </a:r>
             <a:r>
               <a:rPr sz="1500" b="1">
@@ -9418,7 +9418,7 @@
         </p:nvGraphicFramePr>
         <p:xfrm>
           <a:off x="502920" y="1633727"/>
-          <a:ext cx="11185852" cy="848676"/>
+          <a:ext cx="11185852" cy="1185862"/>
         </p:xfrm>
         <a:graphic>
           <a:graphicData uri="http://schemas.openxmlformats.org/drawingml/2006/table">
@@ -9492,7 +9492,7 @@
                           </a:solidFill>
                           <a:latin typeface="맑은 고딕"/>
                         </a:rPr>
-                        <a:t>L2 핵심 업무</a:t>
+                        <a:t>L2 관련(핵심) 업무</a:t>
                       </a:r>
                     </a:p>
                   </a:txBody>
@@ -9526,22 +9526,13 @@
                   </a:tcPr>
                 </a:tc>
               </a:tr>
-              <a:tr h="282892">
-                <a:tc>
-                  <a:txBody>
-                    <a:bodyPr wrap="square"/>
-                    <a:lstStyle/>
-                    <a:p>
-                      <a:pPr algn="l"/>
-                      <a:r>
-                        <a:rPr sz="1050" b="0">
-                          <a:solidFill>
-                            <a:srgbClr val="262626"/>
-                          </a:solidFill>
-                          <a:latin typeface="맑은 고딕"/>
-                        </a:rPr>
-                        <a:t>신규 공정 셋업 </a:t>
-                      </a:r>
+              <a:tr h="902970">
+                <a:tc>
+                  <a:txBody>
+                    <a:bodyPr wrap="square"/>
+                    <a:lstStyle/>
+                    <a:p>
+                      <a:pPr algn="l"/>
                       <a:r>
                         <a:rPr sz="1050" b="1">
                           <a:solidFill>
@@ -9549,54 +9540,128 @@
                           </a:solidFill>
                           <a:latin typeface="맑은 고딕"/>
                         </a:rPr>
-                        <a:t>리드타임 단축</a:t>
-                      </a:r>
-                    </a:p>
-                  </a:txBody>
-                  <a:tcPr marL="54864" marR="54864" marT="18288" marB="18288" anchor="ctr">
-                    <a:solidFill>
-                      <a:srgbClr val="FFFFFF"/>
-                    </a:solidFill>
-                  </a:tcPr>
-                </a:tc>
-                <a:tc>
-                  <a:txBody>
-                    <a:bodyPr wrap="square"/>
-                    <a:lstStyle/>
-                    <a:p>
-                      <a:pPr algn="l"/>
-                      <a:r>
-                        <a:rPr sz="1050" b="0">
-                          <a:solidFill>
-                            <a:srgbClr val="262626"/>
-                          </a:solidFill>
-                          <a:latin typeface="맑은 고딕"/>
-                        </a:rPr>
-                        <a:t>① Recipe Setup 처리량 확대</a:t>
-                      </a:r>
-                    </a:p>
-                  </a:txBody>
-                  <a:tcPr marL="54864" marR="54864" marT="18288" marB="18288" anchor="ctr">
-                    <a:solidFill>
-                      <a:srgbClr val="FFFFFF"/>
-                    </a:solidFill>
-                  </a:tcPr>
-                </a:tc>
-                <a:tc>
-                  <a:txBody>
-                    <a:bodyPr wrap="square"/>
-                    <a:lstStyle/>
-                    <a:p>
-                      <a:pPr algn="l"/>
-                      <a:r>
-                        <a:rPr sz="1050" b="0">
-                          <a:solidFill>
-                            <a:srgbClr val="262626"/>
-                          </a:solidFill>
-                          <a:latin typeface="맑은 고딕"/>
-                        </a:rPr>
-                        <a:t>CD-SEM </a:t>
-                      </a:r>
+                        <a:t>R&amp;D 디바이스 개발 지연 최소화</a:t>
+                      </a:r>
+                    </a:p>
+                  </a:txBody>
+                  <a:tcPr marL="54864" marR="54864" marT="18288" marB="18288" anchor="ctr">
+                    <a:solidFill>
+                      <a:srgbClr val="FFFFFF"/>
+                    </a:solidFill>
+                  </a:tcPr>
+                </a:tc>
+                <a:tc>
+                  <a:txBody>
+                    <a:bodyPr wrap="square"/>
+                    <a:lstStyle/>
+                    <a:p>
+                      <a:pPr algn="l"/>
+                      <a:r>
+                        <a:rPr sz="1050" b="0">
+                          <a:solidFill>
+                            <a:srgbClr val="262626"/>
+                          </a:solidFill>
+                          <a:latin typeface="맑은 고딕"/>
+                        </a:rPr>
+                        <a:t>① 검/계측 효율화</a:t>
+                      </a:r>
+                    </a:p>
+                    <a:p>
+                      <a:pPr algn="l"/>
+                      <a:r>
+                        <a:rPr sz="1050" b="0">
+                          <a:solidFill>
+                            <a:srgbClr val="262626"/>
+                          </a:solidFill>
+                          <a:latin typeface="맑은 고딕"/>
+                        </a:rPr>
+                        <a:t>② 장비 운영/관리 최적화</a:t>
+                      </a:r>
+                    </a:p>
+                    <a:p>
+                      <a:pPr algn="l"/>
+                      <a:r>
+                        <a:rPr sz="1050" b="0">
+                          <a:solidFill>
+                            <a:srgbClr val="262626"/>
+                          </a:solidFill>
+                          <a:latin typeface="맑은 고딕"/>
+                        </a:rPr>
+                        <a:t>③ 장비 개발·도입</a:t>
+                      </a:r>
+                    </a:p>
+                  </a:txBody>
+                  <a:tcPr marL="54864" marR="54864" marT="18288" marB="18288" anchor="ctr">
+                    <a:solidFill>
+                      <a:srgbClr val="FFFFFF"/>
+                    </a:solidFill>
+                  </a:tcPr>
+                </a:tc>
+                <a:tc>
+                  <a:txBody>
+                    <a:bodyPr wrap="square"/>
+                    <a:lstStyle/>
+                    <a:p>
+                      <a:pPr algn="l"/>
+                      <a:r>
+                        <a:rPr sz="1050" b="0">
+                          <a:solidFill>
+                            <a:srgbClr val="262626"/>
+                          </a:solidFill>
+                          <a:latin typeface="맑은 고딕"/>
+                        </a:rPr>
+                        <a:t>① MI Recipe Solution 제공</a:t>
+                      </a:r>
+                    </a:p>
+                    <a:p>
+                      <a:pPr algn="l"/>
+                      <a:r>
+                        <a:rPr sz="1050" b="0">
+                          <a:solidFill>
+                            <a:srgbClr val="262626"/>
+                          </a:solidFill>
+                          <a:latin typeface="맑은 고딕"/>
+                        </a:rPr>
+                        <a:t>② 측정 장비 간 Skew Zero</a:t>
+                      </a:r>
+                    </a:p>
+                    <a:p>
+                      <a:pPr algn="l"/>
+                      <a:r>
+                        <a:rPr sz="1050" b="0">
+                          <a:solidFill>
+                            <a:srgbClr val="262626"/>
+                          </a:solidFill>
+                          <a:latin typeface="맑은 고딕"/>
+                        </a:rPr>
+                        <a:t>③ MI 장비 가동률 극대화</a:t>
+                      </a:r>
+                    </a:p>
+                    <a:p>
+                      <a:pPr algn="l"/>
+                      <a:r>
+                        <a:rPr sz="1050" b="0">
+                          <a:solidFill>
+                            <a:srgbClr val="262626"/>
+                          </a:solidFill>
+                          <a:latin typeface="맑은 고딕"/>
+                        </a:rPr>
+                        <a:t>④ 장비 개발·도입 및 양산 이관</a:t>
+                      </a:r>
+                    </a:p>
+                  </a:txBody>
+                  <a:tcPr marL="54864" marR="54864" marT="18288" marB="18288" anchor="ctr">
+                    <a:solidFill>
+                      <a:srgbClr val="FFFFFF"/>
+                    </a:solidFill>
+                  </a:tcPr>
+                </a:tc>
+                <a:tc>
+                  <a:txBody>
+                    <a:bodyPr wrap="square"/>
+                    <a:lstStyle/>
+                    <a:p>
+                      <a:pPr algn="l"/>
                       <a:r>
                         <a:rPr sz="1050" b="1">
                           <a:solidFill>
@@ -9604,142 +9669,19 @@
                           </a:solidFill>
                           <a:latin typeface="맑은 고딕"/>
                         </a:rPr>
-                        <a:t>Recipe Creation</a:t>
-                      </a:r>
-                    </a:p>
-                  </a:txBody>
-                  <a:tcPr marL="54864" marR="54864" marT="18288" marB="18288" anchor="ctr">
-                    <a:solidFill>
-                      <a:srgbClr val="FFFFFF"/>
-                    </a:solidFill>
-                  </a:tcPr>
-                </a:tc>
-                <a:tc>
-                  <a:txBody>
-                    <a:bodyPr wrap="square"/>
-                    <a:lstStyle/>
-                    <a:p>
-                      <a:pPr algn="l"/>
-                      <a:r>
-                        <a:rPr sz="1050" b="0">
-                          <a:solidFill>
-                            <a:srgbClr val="262626"/>
-                          </a:solidFill>
-                          <a:latin typeface="맑은 고딕"/>
-                        </a:rPr>
-                        <a:t>① VLM GUI-제어 Recipe 자동 생성</a:t>
-                      </a:r>
-                    </a:p>
-                  </a:txBody>
-                  <a:tcPr marL="54864" marR="54864" marT="18288" marB="18288" anchor="ctr">
-                    <a:solidFill>
-                      <a:srgbClr val="FFFFFF"/>
-                    </a:solidFill>
-                  </a:tcPr>
-                </a:tc>
-              </a:tr>
-              <a:tr h="282892">
-                <a:tc>
-                  <a:txBody>
-                    <a:bodyPr wrap="square"/>
-                    <a:lstStyle/>
-                    <a:p>
-                      <a:pPr algn="l"/>
-                      <a:r>
-                        <a:rPr sz="1050" b="0">
-                          <a:solidFill>
-                            <a:srgbClr val="262626"/>
-                          </a:solidFill>
-                          <a:latin typeface="맑은 고딕"/>
-                        </a:rPr>
-                        <a:t>〃</a:t>
-                      </a:r>
-                    </a:p>
-                  </a:txBody>
-                  <a:tcPr marL="54864" marR="54864" marT="18288" marB="18288" anchor="ctr">
-                    <a:solidFill>
-                      <a:srgbClr val="FFFFFF"/>
-                    </a:solidFill>
-                  </a:tcPr>
-                </a:tc>
-                <a:tc>
-                  <a:txBody>
-                    <a:bodyPr wrap="square"/>
-                    <a:lstStyle/>
-                    <a:p>
-                      <a:pPr algn="l"/>
-                      <a:r>
-                        <a:rPr sz="1050" b="0">
-                          <a:solidFill>
-                            <a:srgbClr val="262626"/>
-                          </a:solidFill>
-                          <a:latin typeface="맑은 고딕"/>
-                        </a:rPr>
-                        <a:t>② 숙련도 편차 제거 + 24h 무중단</a:t>
-                      </a:r>
-                    </a:p>
-                  </a:txBody>
-                  <a:tcPr marL="54864" marR="54864" marT="18288" marB="18288" anchor="ctr">
-                    <a:solidFill>
-                      <a:srgbClr val="FFFFFF"/>
-                    </a:solidFill>
-                  </a:tcPr>
-                </a:tc>
-                <a:tc>
-                  <a:txBody>
-                    <a:bodyPr wrap="square"/>
-                    <a:lstStyle/>
-                    <a:p>
-                      <a:pPr algn="l"/>
-                      <a:r>
-                        <a:rPr sz="1050" b="0">
-                          <a:solidFill>
-                            <a:srgbClr val="262626"/>
-                          </a:solidFill>
-                          <a:latin typeface="맑은 고딕"/>
-                        </a:rPr>
-                        <a:t>〃</a:t>
-                      </a:r>
-                    </a:p>
-                  </a:txBody>
-                  <a:tcPr marL="54864" marR="54864" marT="18288" marB="18288" anchor="ctr">
-                    <a:solidFill>
-                      <a:srgbClr val="FFFFFF"/>
-                    </a:solidFill>
-                  </a:tcPr>
-                </a:tc>
-                <a:tc>
-                  <a:txBody>
-                    <a:bodyPr wrap="square"/>
-                    <a:lstStyle/>
-                    <a:p>
-                      <a:pPr algn="l"/>
-                      <a:r>
-                        <a:rPr sz="1050" b="0">
-                          <a:solidFill>
-                            <a:srgbClr val="262626"/>
-                          </a:solidFill>
-                          <a:latin typeface="맑은 고딕"/>
-                        </a:rPr>
-                        <a:t>② 실측 좌표·align </a:t>
-                      </a:r>
-                      <a:r>
-                        <a:rPr sz="1050" b="1">
-                          <a:solidFill>
-                            <a:srgbClr val="262626"/>
-                          </a:solidFill>
-                          <a:latin typeface="맑은 고딕"/>
-                        </a:rPr>
-                        <a:t>자동 보정</a:t>
-                      </a:r>
-                      <a:r>
-                        <a:rPr sz="1050" b="0">
-                          <a:solidFill>
-                            <a:srgbClr val="262626"/>
-                          </a:solidFill>
-                          <a:latin typeface="맑은 고딕"/>
-                        </a:rPr>
-                        <a:t> (핵심)</a:t>
+                        <a:t>Auto Recipe Creation</a:t>
+                      </a:r>
+                    </a:p>
+                    <a:p>
+                      <a:pPr algn="l"/>
+                      <a:r>
+                        <a:rPr sz="1050" b="0">
+                          <a:solidFill>
+                            <a:srgbClr val="262626"/>
+                          </a:solidFill>
+                          <a:latin typeface="맑은 고딕"/>
+                        </a:rPr>
+                        <a:t>(1차 PoC = Align fail 대응 자동화)</a:t>
                       </a:r>
                     </a:p>
                   </a:txBody>
@@ -9762,8 +9704,8 @@
         </p:nvSpPr>
         <p:spPr>
           <a:xfrm>
-            <a:off x="548640" y="2592131"/>
-            <a:ext cx="11185855" cy="332359"/>
+            <a:off x="548640" y="2929317"/>
+            <a:ext cx="11185855" cy="609854"/>
           </a:xfrm>
           <a:prstGeom prst="rect">
             <a:avLst/>
@@ -9799,7 +9741,7 @@
                 </a:solidFill>
                 <a:latin typeface="맑은 고딕"/>
               </a:rPr>
-              <a:t>: L3 후보가 L2→L1→L0로 끊김 없이 거슬러 올라감 → </a:t>
+              <a:t>: L3 과제(Auto Recipe Creation)가 핵심업무 ①~③→L1→L0로 끊김 없이 거슬러 올라감 → </a:t>
             </a:r>
             <a:r>
               <a:rPr sz="1150" b="1">
@@ -9817,7 +9759,7 @@
                 </a:solidFill>
                 <a:latin typeface="맑은 고딕"/>
               </a:rPr>
-              <a:t>. 두 후보는 별개가 아니라 </a:t>
+              <a:t>. 후보 과제는 하나이며, </a:t>
             </a:r>
             <a:r>
               <a:rPr sz="1150" b="1">
@@ -9835,7 +9777,7 @@
                 </a:solidFill>
                 <a:latin typeface="맑은 고딕"/>
               </a:rPr>
-              <a:t>(②~⑥ 연속, ⑥ 핵심)로 묶인다.</a:t>
+              <a:t>(②~⑥ 연속)가 수행하되 ⑥(Align fail 대응 자동화 = Smart Align Agent)을 1차 PoC로 둔다. (핵심업무 ④ 장비 개발·양산 이관은 업무 목표 ③ 추적용으로 ARC 범위 밖.)</a:t>
             </a:r>
           </a:p>
         </p:txBody>
@@ -9979,7 +9921,7 @@
         <p:spPr>
           <a:xfrm>
             <a:off x="548640" y="1234440"/>
-            <a:ext cx="11185855" cy="344423"/>
+            <a:ext cx="11185855" cy="633983"/>
           </a:xfrm>
           <a:prstGeom prst="rect">
             <a:avLst/>
@@ -10017,7 +9959,7 @@
                 </a:solidFill>
                 <a:latin typeface="맑은 고딕"/>
               </a:rPr>
-              <a:t>. (L2 4분할 = 엔지니어 확정 2026-06-24)</a:t>
+              <a:t>. (L2 4분할 = 엔지니어 확정 2026-06-24 → R&amp;D 컨텍스트 재확정 2026-06-29: 구 "측정 실행(양산 Run)" 삭제, "장비 개발 &amp; 양산 이관" 신설)</a:t>
             </a:r>
           </a:p>
         </p:txBody>
@@ -10031,7 +9973,7 @@
           <p:nvPr/>
         </p:nvGraphicFramePr>
         <p:xfrm>
-          <a:off x="502920" y="1633727"/>
+          <a:off x="502920" y="1923287"/>
           <a:ext cx="11185852" cy="1621153"/>
         </p:xfrm>
         <a:graphic>
@@ -10275,76 +10217,76 @@
                           </a:solidFill>
                           <a:latin typeface="맑은 고딕"/>
                         </a:rPr>
-                        <a:t>B. 측정 실행</a:t>
-                      </a:r>
-                    </a:p>
-                  </a:txBody>
-                  <a:tcPr marL="54864" marR="54864" marT="18288" marB="18288" anchor="ctr">
-                    <a:solidFill>
-                      <a:srgbClr val="FFFFFF"/>
-                    </a:solidFill>
-                  </a:tcPr>
-                </a:tc>
-                <a:tc>
-                  <a:txBody>
-                    <a:bodyPr wrap="square"/>
-                    <a:lstStyle/>
-                    <a:p>
-                      <a:pPr algn="l"/>
-                      <a:r>
-                        <a:rPr sz="1050" b="0">
-                          <a:solidFill>
-                            <a:srgbClr val="262626"/>
-                          </a:solidFill>
-                          <a:latin typeface="맑은 고딕"/>
-                        </a:rPr>
-                        <a:t>② 자동 측정 Run</a:t>
-                      </a:r>
-                    </a:p>
-                  </a:txBody>
-                  <a:tcPr marL="54864" marR="54864" marT="18288" marB="18288" anchor="ctr">
-                    <a:solidFill>
-                      <a:srgbClr val="FFFFFF"/>
-                    </a:solidFill>
-                  </a:tcPr>
-                </a:tc>
-                <a:tc>
-                  <a:txBody>
-                    <a:bodyPr wrap="square"/>
-                    <a:lstStyle/>
-                    <a:p>
-                      <a:pPr algn="l"/>
-                      <a:r>
-                        <a:rPr sz="1050" b="0">
-                          <a:solidFill>
-                            <a:srgbClr val="262626"/>
-                          </a:solidFill>
-                          <a:latin typeface="맑은 고딕"/>
-                        </a:rPr>
-                        <a:t>⚙️</a:t>
-                      </a:r>
-                    </a:p>
-                  </a:txBody>
-                  <a:tcPr marL="54864" marR="54864" marT="18288" marB="18288" anchor="ctr">
-                    <a:solidFill>
-                      <a:srgbClr val="FFFFFF"/>
-                    </a:solidFill>
-                  </a:tcPr>
-                </a:tc>
-                <a:tc>
-                  <a:txBody>
-                    <a:bodyPr wrap="square"/>
-                    <a:lstStyle/>
-                    <a:p>
-                      <a:pPr algn="l"/>
-                      <a:r>
-                        <a:rPr sz="1050" b="0">
-                          <a:solidFill>
-                            <a:srgbClr val="262626"/>
-                          </a:solidFill>
-                          <a:latin typeface="맑은 고딕"/>
-                        </a:rPr>
-                        <a:t>이미 자동화 — 범위 밖</a:t>
+                        <a:t>B. 장비 운영/관리</a:t>
+                      </a:r>
+                    </a:p>
+                  </a:txBody>
+                  <a:tcPr marL="54864" marR="54864" marT="18288" marB="18288" anchor="ctr">
+                    <a:solidFill>
+                      <a:srgbClr val="FFFFFF"/>
+                    </a:solidFill>
+                  </a:tcPr>
+                </a:tc>
+                <a:tc>
+                  <a:txBody>
+                    <a:bodyPr wrap="square"/>
+                    <a:lstStyle/>
+                    <a:p>
+                      <a:pPr algn="l"/>
+                      <a:r>
+                        <a:rPr sz="1050" b="0">
+                          <a:solidFill>
+                            <a:srgbClr val="262626"/>
+                          </a:solidFill>
+                          <a:latin typeface="맑은 고딕"/>
+                        </a:rPr>
+                        <a:t>① BM/PM · ③ 캘리브레이션</a:t>
+                      </a:r>
+                    </a:p>
+                  </a:txBody>
+                  <a:tcPr marL="54864" marR="54864" marT="18288" marB="18288" anchor="ctr">
+                    <a:solidFill>
+                      <a:srgbClr val="FFFFFF"/>
+                    </a:solidFill>
+                  </a:tcPr>
+                </a:tc>
+                <a:tc>
+                  <a:txBody>
+                    <a:bodyPr wrap="square"/>
+                    <a:lstStyle/>
+                    <a:p>
+                      <a:pPr algn="l"/>
+                      <a:r>
+                        <a:rPr sz="1050" b="0">
+                          <a:solidFill>
+                            <a:srgbClr val="262626"/>
+                          </a:solidFill>
+                          <a:latin typeface="맑은 고딕"/>
+                        </a:rPr>
+                        <a:t>🧑</a:t>
+                      </a:r>
+                    </a:p>
+                  </a:txBody>
+                  <a:tcPr marL="54864" marR="54864" marT="18288" marB="18288" anchor="ctr">
+                    <a:solidFill>
+                      <a:srgbClr val="FFFFFF"/>
+                    </a:solidFill>
+                  </a:tcPr>
+                </a:tc>
+                <a:tc>
+                  <a:txBody>
+                    <a:bodyPr wrap="square"/>
+                    <a:lstStyle/>
+                    <a:p>
+                      <a:pPr algn="l"/>
+                      <a:r>
+                        <a:rPr sz="1050" b="0">
+                          <a:solidFill>
+                            <a:srgbClr val="262626"/>
+                          </a:solidFill>
+                          <a:latin typeface="맑은 고딕"/>
+                        </a:rPr>
+                        <a:t>물리 보전 — 범위 밖</a:t>
                       </a:r>
                     </a:p>
                   </a:txBody>
@@ -10369,30 +10311,30 @@
                           </a:solidFill>
                           <a:latin typeface="맑은 고딕"/>
                         </a:rPr>
-                        <a:t>C. 데이터·모니터링</a:t>
-                      </a:r>
-                    </a:p>
-                  </a:txBody>
-                  <a:tcPr marL="54864" marR="54864" marT="18288" marB="18288" anchor="ctr">
-                    <a:solidFill>
-                      <a:srgbClr val="FFFFFF"/>
-                    </a:solidFill>
-                  </a:tcPr>
-                </a:tc>
-                <a:tc>
-                  <a:txBody>
-                    <a:bodyPr wrap="square"/>
-                    <a:lstStyle/>
-                    <a:p>
-                      <a:pPr algn="l"/>
-                      <a:r>
-                        <a:rPr sz="1050" b="0">
-                          <a:solidFill>
-                            <a:srgbClr val="262626"/>
-                          </a:solidFill>
-                          <a:latin typeface="맑은 고딕"/>
-                        </a:rPr>
-                        <a:t>② 안정성 모니터링 ◇</a:t>
+                        <a:t>C. 계측 데이터·모니터링</a:t>
+                      </a:r>
+                    </a:p>
+                  </a:txBody>
+                  <a:tcPr marL="54864" marR="54864" marT="18288" marB="18288" anchor="ctr">
+                    <a:solidFill>
+                      <a:srgbClr val="FFFFFF"/>
+                    </a:solidFill>
+                  </a:tcPr>
+                </a:tc>
+                <a:tc>
+                  <a:txBody>
+                    <a:bodyPr wrap="square"/>
+                    <a:lstStyle/>
+                    <a:p>
+                      <a:pPr algn="l"/>
+                      <a:r>
+                        <a:rPr sz="1050" b="0">
+                          <a:solidFill>
+                            <a:srgbClr val="262626"/>
+                          </a:solidFill>
+                          <a:latin typeface="맑은 고딕"/>
+                        </a:rPr>
+                        <a:t>① Recipe 준수 모니터링 ◇</a:t>
                       </a:r>
                     </a:p>
                   </a:txBody>
@@ -10472,30 +10414,30 @@
                           </a:solidFill>
                           <a:latin typeface="맑은 고딕"/>
                         </a:rPr>
-                        <a:t>D. 장비 유지보수</a:t>
-                      </a:r>
-                    </a:p>
-                  </a:txBody>
-                  <a:tcPr marL="54864" marR="54864" marT="18288" marB="18288" anchor="ctr">
-                    <a:solidFill>
-                      <a:srgbClr val="FFFFFF"/>
-                    </a:solidFill>
-                  </a:tcPr>
-                </a:tc>
-                <a:tc>
-                  <a:txBody>
-                    <a:bodyPr wrap="square"/>
-                    <a:lstStyle/>
-                    <a:p>
-                      <a:pPr algn="l"/>
-                      <a:r>
-                        <a:rPr sz="1050" b="0">
-                          <a:solidFill>
-                            <a:srgbClr val="262626"/>
-                          </a:solidFill>
-                          <a:latin typeface="맑은 고딕"/>
-                        </a:rPr>
-                        <a:t>① PM · ③ 캘리브레이션</a:t>
+                        <a:t>D. 장비 개발 &amp; 양산 이관</a:t>
+                      </a:r>
+                    </a:p>
+                  </a:txBody>
+                  <a:tcPr marL="54864" marR="54864" marT="18288" marB="18288" anchor="ctr">
+                    <a:solidFill>
+                      <a:srgbClr val="FFFFFF"/>
+                    </a:solidFill>
+                  </a:tcPr>
+                </a:tc>
+                <a:tc>
+                  <a:txBody>
+                    <a:bodyPr wrap="square"/>
+                    <a:lstStyle/>
+                    <a:p>
+                      <a:pPr algn="l"/>
+                      <a:r>
+                        <a:rPr sz="1050" b="0">
+                          <a:solidFill>
+                            <a:srgbClr val="262626"/>
+                          </a:solidFill>
+                          <a:latin typeface="맑은 고딕"/>
+                        </a:rPr>
+                        <a:t>② 장비 개발(BP社) · ④ 양산 이관</a:t>
                       </a:r>
                     </a:p>
                   </a:txBody>
@@ -10541,7 +10483,7 @@
                           </a:solidFill>
                           <a:latin typeface="맑은 고딕"/>
                         </a:rPr>
-                        <a:t>물리 작업 — 범위 밖</a:t>
+                        <a:t>외부 협력·이관 행정 — 범위 밖</a:t>
                       </a:r>
                     </a:p>
                   </a:txBody>
@@ -10564,8 +10506,8 @@
         </p:nvSpPr>
         <p:spPr>
           <a:xfrm>
-            <a:off x="548640" y="3364608"/>
-            <a:ext cx="11185855" cy="332359"/>
+            <a:off x="548640" y="3654168"/>
+            <a:ext cx="11185855" cy="609854"/>
           </a:xfrm>
           <a:prstGeom prst="rect">
             <a:avLst/>
@@ -10610,7 +10552,7 @@
                 </a:solidFill>
                 <a:latin typeface="맑은 고딕"/>
               </a:rPr>
-              <a:t> — 반복성·정형성·공수·데이터 가용성이 큰 지점만 선별.</a:t>
+              <a:t> — 반복성·정형성·공수·데이터 가용성이 큰 지점만 선별. ※ 양산은 R&amp;D 운영 대상이 아니라 개발 완료품을 양산으로 넘기는 별도 이관 업무(D 영역).</a:t>
             </a:r>
           </a:p>
         </p:txBody>
@@ -10807,7 +10749,7 @@
         </p:nvGraphicFramePr>
         <p:xfrm>
           <a:off x="502920" y="1633727"/>
-          <a:ext cx="11185855" cy="1621153"/>
+          <a:ext cx="11185855" cy="2034538"/>
         </p:xfrm>
         <a:graphic>
           <a:graphicData uri="http://schemas.openxmlformats.org/drawingml/2006/table">
@@ -11173,6 +11115,159 @@
                   </a:tcPr>
                 </a:tc>
               </a:tr>
+              <a:tr h="696277">
+                <a:tc>
+                  <a:txBody>
+                    <a:bodyPr wrap="square"/>
+                    <a:lstStyle/>
+                    <a:p>
+                      <a:pPr algn="l"/>
+                      <a:r>
+                        <a:rPr sz="1050" b="1">
+                          <a:solidFill>
+                            <a:srgbClr val="262626"/>
+                          </a:solidFill>
+                          <a:latin typeface="맑은 고딕"/>
+                        </a:rPr>
+                        <a:t>⑥ 시험측정→오인식 수정</a:t>
+                      </a:r>
+                    </a:p>
+                  </a:txBody>
+                  <a:tcPr marL="54864" marR="54864" marT="18288" marB="18288" anchor="ctr">
+                    <a:solidFill>
+                      <a:srgbClr val="FFFFFF"/>
+                    </a:solidFill>
+                  </a:tcPr>
+                </a:tc>
+                <a:tc>
+                  <a:txBody>
+                    <a:bodyPr wrap="square"/>
+                    <a:lstStyle/>
+                    <a:p>
+                      <a:pPr algn="l"/>
+                      <a:r>
+                        <a:rPr sz="1050" b="0">
+                          <a:solidFill>
+                            <a:srgbClr val="262626"/>
+                          </a:solidFill>
+                          <a:latin typeface="맑은 고딕"/>
+                        </a:rPr>
+                        <a:t>공정 variation 이미지 차이로 오측·align 실패·오인식 → </a:t>
+                      </a:r>
+                      <a:r>
+                        <a:rPr sz="1050" b="1">
+                          <a:solidFill>
+                            <a:srgbClr val="262626"/>
+                          </a:solidFill>
+                          <a:latin typeface="맑은 고딕"/>
+                        </a:rPr>
+                        <a:t>반복</a:t>
+                      </a:r>
+                      <a:r>
+                        <a:rPr sz="1050" b="0">
+                          <a:solidFill>
+                            <a:srgbClr val="262626"/>
+                          </a:solidFill>
+                          <a:latin typeface="맑은 고딕"/>
+                        </a:rPr>
+                        <a:t> 수정 (</a:t>
+                      </a:r>
+                      <a:r>
+                        <a:rPr sz="1050" b="1">
+                          <a:solidFill>
+                            <a:srgbClr val="262626"/>
+                          </a:solidFill>
+                          <a:latin typeface="맑은 고딕"/>
+                        </a:rPr>
+                        <a:t>Recipe Mgmt 최대 병목</a:t>
+                      </a:r>
+                      <a:r>
+                        <a:rPr sz="1050" b="0">
+                          <a:solidFill>
+                            <a:srgbClr val="262626"/>
+                          </a:solidFill>
+                          <a:latin typeface="맑은 고딕"/>
+                        </a:rPr>
+                        <a:t>)</a:t>
+                      </a:r>
+                    </a:p>
+                  </a:txBody>
+                  <a:tcPr marL="54864" marR="54864" marT="18288" marB="18288" anchor="ctr">
+                    <a:solidFill>
+                      <a:srgbClr val="FFFFFF"/>
+                    </a:solidFill>
+                  </a:tcPr>
+                </a:tc>
+                <a:tc>
+                  <a:txBody>
+                    <a:bodyPr wrap="square"/>
+                    <a:lstStyle/>
+                    <a:p>
+                      <a:pPr algn="l"/>
+                      <a:r>
+                        <a:rPr sz="1050" b="1">
+                          <a:solidFill>
+                            <a:srgbClr val="262626"/>
+                          </a:solidFill>
+                          <a:latin typeface="맑은 고딕"/>
+                        </a:rPr>
+                        <a:t>5</a:t>
+                      </a:r>
+                    </a:p>
+                  </a:txBody>
+                  <a:tcPr marL="54864" marR="54864" marT="18288" marB="18288" anchor="ctr">
+                    <a:solidFill>
+                      <a:srgbClr val="FFFFFF"/>
+                    </a:solidFill>
+                  </a:tcPr>
+                </a:tc>
+                <a:tc>
+                  <a:txBody>
+                    <a:bodyPr wrap="square"/>
+                    <a:lstStyle/>
+                    <a:p>
+                      <a:pPr algn="l"/>
+                      <a:r>
+                        <a:rPr sz="1050" b="1">
+                          <a:solidFill>
+                            <a:srgbClr val="262626"/>
+                          </a:solidFill>
+                          <a:latin typeface="맑은 고딕"/>
+                        </a:rPr>
+                        <a:t>5</a:t>
+                      </a:r>
+                    </a:p>
+                  </a:txBody>
+                  <a:tcPr marL="54864" marR="54864" marT="18288" marB="18288" anchor="ctr">
+                    <a:solidFill>
+                      <a:srgbClr val="FFFFFF"/>
+                    </a:solidFill>
+                  </a:tcPr>
+                </a:tc>
+                <a:tc>
+                  <a:txBody>
+                    <a:bodyPr wrap="square"/>
+                    <a:lstStyle/>
+                    <a:p>
+                      <a:pPr algn="l"/>
+                      <a:r>
+                        <a:rPr sz="1050" b="1">
+                          <a:solidFill>
+                            <a:srgbClr val="262626"/>
+                          </a:solidFill>
+                          <a:latin typeface="맑은 고딕"/>
+                        </a:rPr>
+                        <a:t>5</a:t>
+                      </a:r>
+                    </a:p>
+                  </a:txBody>
+                  <a:tcPr marL="54864" marR="54864" marT="18288" marB="18288" anchor="ctr">
+                    <a:solidFill>
+                      <a:srgbClr val="FFFFFF"/>
+                    </a:solidFill>
+                  </a:tcPr>
+                </a:tc>
+              </a:tr>
               <a:tr h="489585">
                 <a:tc>
                   <a:txBody>
@@ -11181,159 +11276,6 @@
                     <a:p>
                       <a:pPr algn="l"/>
                       <a:r>
-                        <a:rPr sz="1050" b="1">
-                          <a:solidFill>
-                            <a:srgbClr val="262626"/>
-                          </a:solidFill>
-                          <a:latin typeface="맑은 고딕"/>
-                        </a:rPr>
-                        <a:t>⑥ 시험측정→오인식 수정</a:t>
-                      </a:r>
-                    </a:p>
-                  </a:txBody>
-                  <a:tcPr marL="54864" marR="54864" marT="18288" marB="18288" anchor="ctr">
-                    <a:solidFill>
-                      <a:srgbClr val="FFFFFF"/>
-                    </a:solidFill>
-                  </a:tcPr>
-                </a:tc>
-                <a:tc>
-                  <a:txBody>
-                    <a:bodyPr wrap="square"/>
-                    <a:lstStyle/>
-                    <a:p>
-                      <a:pPr algn="l"/>
-                      <a:r>
-                        <a:rPr sz="1050" b="0">
-                          <a:solidFill>
-                            <a:srgbClr val="262626"/>
-                          </a:solidFill>
-                          <a:latin typeface="맑은 고딕"/>
-                        </a:rPr>
-                        <a:t>좌표 shift·align 실패·오인식 → 수정 </a:t>
-                      </a:r>
-                      <a:r>
-                        <a:rPr sz="1050" b="1">
-                          <a:solidFill>
-                            <a:srgbClr val="262626"/>
-                          </a:solidFill>
-                          <a:latin typeface="맑은 고딕"/>
-                        </a:rPr>
-                        <a:t>반복</a:t>
-                      </a:r>
-                      <a:r>
-                        <a:rPr sz="1050" b="0">
-                          <a:solidFill>
-                            <a:srgbClr val="262626"/>
-                          </a:solidFill>
-                          <a:latin typeface="맑은 고딕"/>
-                        </a:rPr>
-                        <a:t> (</a:t>
-                      </a:r>
-                      <a:r>
-                        <a:rPr sz="1050" b="1">
-                          <a:solidFill>
-                            <a:srgbClr val="262626"/>
-                          </a:solidFill>
-                          <a:latin typeface="맑은 고딕"/>
-                        </a:rPr>
-                        <a:t>최대 병목</a:t>
-                      </a:r>
-                      <a:r>
-                        <a:rPr sz="1050" b="0">
-                          <a:solidFill>
-                            <a:srgbClr val="262626"/>
-                          </a:solidFill>
-                          <a:latin typeface="맑은 고딕"/>
-                        </a:rPr>
-                        <a:t>)</a:t>
-                      </a:r>
-                    </a:p>
-                  </a:txBody>
-                  <a:tcPr marL="54864" marR="54864" marT="18288" marB="18288" anchor="ctr">
-                    <a:solidFill>
-                      <a:srgbClr val="FFFFFF"/>
-                    </a:solidFill>
-                  </a:tcPr>
-                </a:tc>
-                <a:tc>
-                  <a:txBody>
-                    <a:bodyPr wrap="square"/>
-                    <a:lstStyle/>
-                    <a:p>
-                      <a:pPr algn="l"/>
-                      <a:r>
-                        <a:rPr sz="1050" b="1">
-                          <a:solidFill>
-                            <a:srgbClr val="262626"/>
-                          </a:solidFill>
-                          <a:latin typeface="맑은 고딕"/>
-                        </a:rPr>
-                        <a:t>5</a:t>
-                      </a:r>
-                    </a:p>
-                  </a:txBody>
-                  <a:tcPr marL="54864" marR="54864" marT="18288" marB="18288" anchor="ctr">
-                    <a:solidFill>
-                      <a:srgbClr val="FFFFFF"/>
-                    </a:solidFill>
-                  </a:tcPr>
-                </a:tc>
-                <a:tc>
-                  <a:txBody>
-                    <a:bodyPr wrap="square"/>
-                    <a:lstStyle/>
-                    <a:p>
-                      <a:pPr algn="l"/>
-                      <a:r>
-                        <a:rPr sz="1050" b="1">
-                          <a:solidFill>
-                            <a:srgbClr val="262626"/>
-                          </a:solidFill>
-                          <a:latin typeface="맑은 고딕"/>
-                        </a:rPr>
-                        <a:t>5</a:t>
-                      </a:r>
-                    </a:p>
-                  </a:txBody>
-                  <a:tcPr marL="54864" marR="54864" marT="18288" marB="18288" anchor="ctr">
-                    <a:solidFill>
-                      <a:srgbClr val="FFFFFF"/>
-                    </a:solidFill>
-                  </a:tcPr>
-                </a:tc>
-                <a:tc>
-                  <a:txBody>
-                    <a:bodyPr wrap="square"/>
-                    <a:lstStyle/>
-                    <a:p>
-                      <a:pPr algn="l"/>
-                      <a:r>
-                        <a:rPr sz="1050" b="1">
-                          <a:solidFill>
-                            <a:srgbClr val="262626"/>
-                          </a:solidFill>
-                          <a:latin typeface="맑은 고딕"/>
-                        </a:rPr>
-                        <a:t>5</a:t>
-                      </a:r>
-                    </a:p>
-                  </a:txBody>
-                  <a:tcPr marL="54864" marR="54864" marT="18288" marB="18288" anchor="ctr">
-                    <a:solidFill>
-                      <a:srgbClr val="FFFFFF"/>
-                    </a:solidFill>
-                  </a:tcPr>
-                </a:tc>
-              </a:tr>
-              <a:tr h="282892">
-                <a:tc>
-                  <a:txBody>
-                    <a:bodyPr wrap="square"/>
-                    <a:lstStyle/>
-                    <a:p>
-                      <a:pPr algn="l"/>
-                      <a:r>
                         <a:rPr sz="1050" b="0">
                           <a:solidFill>
                             <a:srgbClr val="262626"/>
@@ -11363,7 +11305,7 @@
                           </a:solidFill>
                           <a:latin typeface="맑은 고딕"/>
                         </a:rPr>
-                        <a:t>검증 누락 시 오류가 양산 Run으로 전파</a:t>
+                        <a:t>검증 누락 시 오류가 후속 측정·양산 이관 후로 전파</a:t>
                       </a:r>
                     </a:p>
                   </a:txBody>
@@ -11455,8 +11397,8 @@
         </p:nvSpPr>
         <p:spPr>
           <a:xfrm>
-            <a:off x="548640" y="3364608"/>
-            <a:ext cx="11185855" cy="332359"/>
+            <a:off x="548640" y="3777993"/>
+            <a:ext cx="11185855" cy="609854"/>
           </a:xfrm>
           <a:prstGeom prst="rect">
             <a:avLst/>
@@ -11492,7 +11434,7 @@
                 </a:solidFill>
                 <a:latin typeface="맑은 고딕"/>
               </a:rPr>
-              <a:t>. 셋업마다 거의 매번 발생(빈도)하고 오측·재셋업으로 직결되며(심각성) 리드타임의 지배적 비중(주요성). 이 점수가 #05 적정성·#10 기대효과의 백데이터.</a:t>
+              <a:t>. Recipe Setup 후 공정 variation으로 실측 이미지가 달라지는 한 상시 재발(빈도)하고 오측·재셋업으로 직결되며(심각성) 리드타임의 지배적 비중(주요성). 이 점수가 #05 적정성·#10 기대효과의 백데이터.</a:t>
             </a:r>
           </a:p>
         </p:txBody>
@@ -12877,7 +12819,7 @@
         </p:nvGraphicFramePr>
         <p:xfrm>
           <a:off x="502920" y="1633727"/>
-          <a:ext cx="11185854" cy="1904045"/>
+          <a:ext cx="11185854" cy="2600323"/>
         </p:xfrm>
         <a:graphic>
           <a:graphicData uri="http://schemas.openxmlformats.org/drawingml/2006/table">
@@ -12998,7 +12940,78 @@
                           </a:solidFill>
                           <a:latin typeface="맑은 고딕"/>
                         </a:rPr>
-                        <a:t>리드타임 단축 · 24h 무중단 · 숙련편차 제거</a:t>
+                        <a:t>검/계측 효율화 · 장비 운영/관리 최적화 · 장비 개발·도입</a:t>
+                      </a:r>
+                    </a:p>
+                  </a:txBody>
+                  <a:tcPr marL="54864" marR="54864" marT="18288" marB="18288" anchor="ctr">
+                    <a:solidFill>
+                      <a:srgbClr val="FFFFFF"/>
+                    </a:solidFill>
+                  </a:tcPr>
+                </a:tc>
+                <a:tc>
+                  <a:txBody>
+                    <a:bodyPr wrap="square"/>
+                    <a:lstStyle/>
+                    <a:p>
+                      <a:pPr algn="l"/>
+                      <a:r>
+                        <a:rPr sz="1050" b="0">
+                          <a:solidFill>
+                            <a:srgbClr val="262626"/>
+                          </a:solidFill>
+                          <a:latin typeface="맑은 고딕"/>
+                        </a:rPr>
+                        <a:t>#01</a:t>
+                      </a:r>
+                    </a:p>
+                  </a:txBody>
+                  <a:tcPr marL="54864" marR="54864" marT="18288" marB="18288" anchor="ctr">
+                    <a:solidFill>
+                      <a:srgbClr val="FFFFFF"/>
+                    </a:solidFill>
+                  </a:tcPr>
+                </a:tc>
+              </a:tr>
+              <a:tr h="489585">
+                <a:tc>
+                  <a:txBody>
+                    <a:bodyPr wrap="square"/>
+                    <a:lstStyle/>
+                    <a:p>
+                      <a:pPr algn="l"/>
+                      <a:r>
+                        <a:rPr sz="1050" b="0">
+                          <a:solidFill>
+                            <a:srgbClr val="262626"/>
+                          </a:solidFill>
+                          <a:latin typeface="맑은 고딕"/>
+                        </a:rPr>
+                        <a:t>관련(핵심) 업무</a:t>
+                      </a:r>
+                    </a:p>
+                  </a:txBody>
+                  <a:tcPr marL="54864" marR="54864" marT="18288" marB="18288" anchor="ctr">
+                    <a:solidFill>
+                      <a:srgbClr val="FFFFFF"/>
+                    </a:solidFill>
+                  </a:tcPr>
+                </a:tc>
+                <a:tc>
+                  <a:txBody>
+                    <a:bodyPr wrap="square"/>
+                    <a:lstStyle/>
+                    <a:p>
+                      <a:pPr algn="l"/>
+                      <a:r>
+                        <a:rPr sz="1050" b="0">
+                          <a:solidFill>
+                            <a:srgbClr val="262626"/>
+                          </a:solidFill>
+                          <a:latin typeface="맑은 고딕"/>
+                        </a:rPr>
+                        <a:t>MI Recipe Solution 제공 · 측정 장비 간 Skew Zero · MI 장비 가동률 극대화 · 장비 개발·도입 및 양산 이관</a:t>
                       </a:r>
                     </a:p>
                   </a:txBody>
@@ -13046,7 +13059,7 @@
                           </a:solidFill>
                           <a:latin typeface="맑은 고딕"/>
                         </a:rPr>
-                        <a:t>핵심 업무</a:t>
+                        <a:t>핵심 업무 구조화</a:t>
                       </a:r>
                     </a:p>
                   </a:txBody>
@@ -13103,7 +13116,7 @@
                   </a:tcPr>
                 </a:tc>
               </a:tr>
-              <a:tr h="282892">
+              <a:tr h="489585">
                 <a:tc>
                   <a:txBody>
                     <a:bodyPr wrap="square"/>
@@ -13140,7 +13153,7 @@
                           </a:solidFill>
                           <a:latin typeface="맑은 고딕"/>
                         </a:rPr>
-                        <a:t>⑥ 오인식 수정 반복 = 최대 병목</a:t>
+                        <a:t>⑥ 공정 variation 이미지 차이 → 오측·인식 실패 반복 수정 = Recipe Mgmt 최대 병목</a:t>
                       </a:r>
                     </a:p>
                   </a:txBody>
@@ -13346,7 +13359,7 @@
         </p:nvSpPr>
         <p:spPr>
           <a:xfrm>
-            <a:off x="548640" y="3647500"/>
+            <a:off x="548640" y="4343778"/>
             <a:ext cx="11185855" cy="332359"/>
           </a:xfrm>
           <a:prstGeom prst="rect">

</xml_diff>